<commit_message>
Add lessons 4-6: attributes, media and links, capstone project
Co-Authored-By: Claude Sonnet 5.5 <noreply@anthropic.com>
Claude-Session: https://claude.ai/code/session_01MzgFKAuWShtwbNzuNAAhGP
</commit_message>
<xml_diff>
--- a/HTML_Fundamentals/decks/Lesson1_Meet_HTML.pptx
+++ b/HTML_Fundamentals/decks/Lesson1_Meet_HTML.pptx
@@ -121,7 +121,7 @@
   <p:extLst>
     <p:ext uri="{521415D9-36F7-43E2-AB2F-B90AF26B5E84}">
       <p14:sectionLst xmlns:p14="http://schemas.microsoft.com/office/powerpoint/2010/main">
-        <p14:section name="Opening" id="{2bcb4c19-03cc-5766-707c-46a1b84623dd}">
+        <p14:section name="Opening" id="{bced7556-16a3-0321-970c-5e019b5186b7}">
           <p14:sldIdLst>
             <p14:sldId id="256"/>
             <p14:sldId id="257"/>
@@ -131,7 +131,7 @@
             <p14:sldId id="261"/>
           </p14:sldIdLst>
         </p14:section>
-        <p14:section name="Tags &amp; elements" id="{dd7cd387-661a-d25d-eb23-e11561cee082}">
+        <p14:section name="Tags &amp; elements" id="{f0c92d9f-5261-b916-9b64-3c65ccc4fdb1}">
           <p14:sldIdLst>
             <p14:sldId id="262"/>
             <p14:sldId id="263"/>

</xml_diff>